<commit_message>
Harden MCP runtime and update presentation template
</commit_message>
<xml_diff>
--- a/mcp-server/assets/presentation.pptx
+++ b/mcp-server/assets/presentation.pptx
@@ -9,22 +9,6 @@
   </p:sldIdLst>
   <p:sldSz cx="18288000" cy="10287000"/>
   <p:notesSz cx="6858000" cy="9144000"/>
-  <p:embeddedFontLst>
-    <p:embeddedFont>
-      <p:font typeface="Montserrat" pitchFamily="2" charset="77"/>
-      <p:regular r:id="rId3"/>
-      <p:bold r:id="rId4"/>
-      <p:italic r:id="rId5"/>
-      <p:boldItalic r:id="rId6"/>
-    </p:embeddedFont>
-    <p:embeddedFont>
-      <p:font typeface="Montserrat SemiBold" pitchFamily="2" charset="77"/>
-      <p:regular r:id="rId7"/>
-      <p:bold r:id="rId8"/>
-      <p:italic r:id="rId9"/>
-      <p:boldItalic r:id="rId10"/>
-    </p:embeddedFont>
-  </p:embeddedFontLst>
   <p:defaultTextStyle>
     <a:defPPr>
       <a:defRPr lang="en-US"/>
@@ -493,10 +477,10 @@
       </p:grpSpPr>
       <p:pic>
         <p:nvPicPr>
-          <p:cNvPr id="22" name="Picture 21">
+          <p:cNvPr id="30" name="Picture 29">
             <a:extLst>
               <a:ext uri="{FF2B5EF4-FFF2-40B4-BE49-F238E27FC236}">
-                <a16:creationId xmlns:a16="http://schemas.microsoft.com/office/drawing/2014/main" id="{CEA23B59-77A8-AB35-EBB9-EAB02B5A3E01}"/>
+                <a16:creationId xmlns:a16="http://schemas.microsoft.com/office/drawing/2014/main" id="{76286C23-898F-5D45-CBEF-FDADAA8F9802}"/>
               </a:ext>
               <a:ext uri="{C183D7F6-B498-43B3-948B-1728B52AA6E4}">
                 <adec:decorative xmlns:adec="http://schemas.microsoft.com/office/drawing/2017/decorative" val="1"/>
@@ -504,7 +488,7 @@
             </a:extLst>
           </p:cNvPr>
           <p:cNvPicPr>
-            <a:picLocks noGrp="1" noRot="1" noChangeAspect="1" noMove="1" noResize="1" noEditPoints="1" noAdjustHandles="1" noChangeArrowheads="1" noChangeShapeType="1" noCrop="1"/>
+            <a:picLocks noChangeAspect="1"/>
           </p:cNvPicPr>
           <p:nvPr/>
         </p:nvPicPr>
@@ -522,532 +506,14 @@
         </p:blipFill>
         <p:spPr>
           <a:xfrm>
-            <a:off x="-1" y="-39804"/>
-            <a:ext cx="18358763" cy="10326804"/>
+            <a:off x="0" y="0"/>
+            <a:ext cx="18288000" cy="10287000"/>
           </a:xfrm>
           <a:prstGeom prst="rect">
             <a:avLst/>
           </a:prstGeom>
         </p:spPr>
       </p:pic>
-      <p:pic>
-        <p:nvPicPr>
-          <p:cNvPr id="46" name="Picture 45" descr="A black and white image of a planet earth&#10;&#10;AI-generated content may be incorrect.">
-            <a:extLst>
-              <a:ext uri="{FF2B5EF4-FFF2-40B4-BE49-F238E27FC236}">
-                <a16:creationId xmlns:a16="http://schemas.microsoft.com/office/drawing/2014/main" id="{80B05BCC-1714-E7E7-35B6-5DE90ED30A61}"/>
-              </a:ext>
-            </a:extLst>
-          </p:cNvPr>
-          <p:cNvPicPr>
-            <a:picLocks noChangeAspect="1"/>
-          </p:cNvPicPr>
-          <p:nvPr/>
-        </p:nvPicPr>
-        <p:blipFill>
-          <a:blip r:embed="rId3">
-            <a:alphaModFix amt="42000"/>
-            <a:extLst>
-              <a:ext uri="{28A0092B-C50C-407E-A947-70E740481C1C}">
-                <a14:useLocalDpi xmlns:a14="http://schemas.microsoft.com/office/drawing/2010/main" val="0"/>
-              </a:ext>
-            </a:extLst>
-          </a:blip>
-          <a:srcRect t="19719"/>
-          <a:stretch>
-            <a:fillRect/>
-          </a:stretch>
-        </p:blipFill>
-        <p:spPr>
-          <a:xfrm>
-            <a:off x="6522067" y="-66219"/>
-            <a:ext cx="6966787" cy="6652490"/>
-          </a:xfrm>
-          <a:prstGeom prst="rect">
-            <a:avLst/>
-          </a:prstGeom>
-        </p:spPr>
-      </p:pic>
-      <p:sp>
-        <p:nvSpPr>
-          <p:cNvPr id="21" name="Rounded Rectangle 20">
-            <a:extLst>
-              <a:ext uri="{FF2B5EF4-FFF2-40B4-BE49-F238E27FC236}">
-                <a16:creationId xmlns:a16="http://schemas.microsoft.com/office/drawing/2014/main" id="{221D7866-0026-DD66-E71A-2445F01B4429}"/>
-              </a:ext>
-            </a:extLst>
-          </p:cNvPr>
-          <p:cNvSpPr/>
-          <p:nvPr/>
-        </p:nvSpPr>
-        <p:spPr>
-          <a:xfrm>
-            <a:off x="285921" y="3771628"/>
-            <a:ext cx="6360296" cy="1252099"/>
-          </a:xfrm>
-          <a:prstGeom prst="roundRect">
-            <a:avLst>
-              <a:gd name="adj" fmla="val 9061"/>
-            </a:avLst>
-          </a:prstGeom>
-          <a:solidFill>
-            <a:schemeClr val="bg1">
-              <a:alpha val="44716"/>
-            </a:schemeClr>
-          </a:solidFill>
-          <a:ln w="0">
-            <a:solidFill>
-              <a:schemeClr val="bg1">
-                <a:lumMod val="75000"/>
-              </a:schemeClr>
-            </a:solidFill>
-          </a:ln>
-        </p:spPr>
-        <p:style>
-          <a:lnRef idx="2">
-            <a:schemeClr val="accent1">
-              <a:shade val="15000"/>
-            </a:schemeClr>
-          </a:lnRef>
-          <a:fillRef idx="1">
-            <a:schemeClr val="accent1"/>
-          </a:fillRef>
-          <a:effectRef idx="0">
-            <a:schemeClr val="accent1"/>
-          </a:effectRef>
-          <a:fontRef idx="minor">
-            <a:schemeClr val="lt1"/>
-          </a:fontRef>
-        </p:style>
-        <p:txBody>
-          <a:bodyPr rtlCol="0" anchor="ctr"/>
-          <a:lstStyle/>
-          <a:p>
-            <a:pPr algn="ctr"/>
-            <a:endParaRPr lang="en-US"/>
-          </a:p>
-        </p:txBody>
-      </p:sp>
-      <p:sp>
-        <p:nvSpPr>
-          <p:cNvPr id="38" name="Rounded Rectangle 37">
-            <a:extLst>
-              <a:ext uri="{FF2B5EF4-FFF2-40B4-BE49-F238E27FC236}">
-                <a16:creationId xmlns:a16="http://schemas.microsoft.com/office/drawing/2014/main" id="{7CCEDB43-6DA6-3E55-D2BF-DE6A7312B8E5}"/>
-              </a:ext>
-            </a:extLst>
-          </p:cNvPr>
-          <p:cNvSpPr/>
-          <p:nvPr/>
-        </p:nvSpPr>
-        <p:spPr>
-          <a:xfrm>
-            <a:off x="285921" y="5143228"/>
-            <a:ext cx="6360296" cy="925502"/>
-          </a:xfrm>
-          <a:prstGeom prst="roundRect">
-            <a:avLst>
-              <a:gd name="adj" fmla="val 9397"/>
-            </a:avLst>
-          </a:prstGeom>
-          <a:solidFill>
-            <a:schemeClr val="bg1">
-              <a:alpha val="44716"/>
-            </a:schemeClr>
-          </a:solidFill>
-          <a:ln w="0">
-            <a:solidFill>
-              <a:schemeClr val="bg1">
-                <a:lumMod val="75000"/>
-              </a:schemeClr>
-            </a:solidFill>
-          </a:ln>
-        </p:spPr>
-        <p:style>
-          <a:lnRef idx="2">
-            <a:schemeClr val="accent1">
-              <a:shade val="15000"/>
-            </a:schemeClr>
-          </a:lnRef>
-          <a:fillRef idx="1">
-            <a:schemeClr val="accent1"/>
-          </a:fillRef>
-          <a:effectRef idx="0">
-            <a:schemeClr val="accent1"/>
-          </a:effectRef>
-          <a:fontRef idx="minor">
-            <a:schemeClr val="lt1"/>
-          </a:fontRef>
-        </p:style>
-        <p:txBody>
-          <a:bodyPr rtlCol="0" anchor="ctr"/>
-          <a:lstStyle/>
-          <a:p>
-            <a:pPr algn="ctr"/>
-            <a:endParaRPr lang="en-US"/>
-          </a:p>
-        </p:txBody>
-      </p:sp>
-      <p:sp>
-        <p:nvSpPr>
-          <p:cNvPr id="39" name="Rounded Rectangle 38">
-            <a:extLst>
-              <a:ext uri="{FF2B5EF4-FFF2-40B4-BE49-F238E27FC236}">
-                <a16:creationId xmlns:a16="http://schemas.microsoft.com/office/drawing/2014/main" id="{EDDF77F1-54CF-7EBB-ABFE-F20E44DC75CF}"/>
-              </a:ext>
-            </a:extLst>
-          </p:cNvPr>
-          <p:cNvSpPr/>
-          <p:nvPr/>
-        </p:nvSpPr>
-        <p:spPr>
-          <a:xfrm>
-            <a:off x="285921" y="6200504"/>
-            <a:ext cx="6360296" cy="925502"/>
-          </a:xfrm>
-          <a:prstGeom prst="roundRect">
-            <a:avLst>
-              <a:gd name="adj" fmla="val 9397"/>
-            </a:avLst>
-          </a:prstGeom>
-          <a:solidFill>
-            <a:schemeClr val="bg1">
-              <a:alpha val="44716"/>
-            </a:schemeClr>
-          </a:solidFill>
-          <a:ln w="0">
-            <a:solidFill>
-              <a:schemeClr val="bg1">
-                <a:lumMod val="75000"/>
-              </a:schemeClr>
-            </a:solidFill>
-          </a:ln>
-        </p:spPr>
-        <p:style>
-          <a:lnRef idx="2">
-            <a:schemeClr val="accent1">
-              <a:shade val="15000"/>
-            </a:schemeClr>
-          </a:lnRef>
-          <a:fillRef idx="1">
-            <a:schemeClr val="accent1"/>
-          </a:fillRef>
-          <a:effectRef idx="0">
-            <a:schemeClr val="accent1"/>
-          </a:effectRef>
-          <a:fontRef idx="minor">
-            <a:schemeClr val="lt1"/>
-          </a:fontRef>
-        </p:style>
-        <p:txBody>
-          <a:bodyPr rtlCol="0" anchor="ctr"/>
-          <a:lstStyle/>
-          <a:p>
-            <a:pPr algn="ctr"/>
-            <a:endParaRPr lang="en-US"/>
-          </a:p>
-        </p:txBody>
-      </p:sp>
-      <p:sp>
-        <p:nvSpPr>
-          <p:cNvPr id="40" name="Rounded Rectangle 39">
-            <a:extLst>
-              <a:ext uri="{FF2B5EF4-FFF2-40B4-BE49-F238E27FC236}">
-                <a16:creationId xmlns:a16="http://schemas.microsoft.com/office/drawing/2014/main" id="{48B4B6A2-2505-369D-3420-5EDF99B54699}"/>
-              </a:ext>
-            </a:extLst>
-          </p:cNvPr>
-          <p:cNvSpPr/>
-          <p:nvPr/>
-        </p:nvSpPr>
-        <p:spPr>
-          <a:xfrm>
-            <a:off x="285921" y="7243492"/>
-            <a:ext cx="6360296" cy="2901026"/>
-          </a:xfrm>
-          <a:prstGeom prst="roundRect">
-            <a:avLst>
-              <a:gd name="adj" fmla="val 3127"/>
-            </a:avLst>
-          </a:prstGeom>
-          <a:solidFill>
-            <a:schemeClr val="bg1">
-              <a:alpha val="44716"/>
-            </a:schemeClr>
-          </a:solidFill>
-          <a:ln w="0">
-            <a:solidFill>
-              <a:schemeClr val="bg1">
-                <a:lumMod val="75000"/>
-              </a:schemeClr>
-            </a:solidFill>
-          </a:ln>
-        </p:spPr>
-        <p:style>
-          <a:lnRef idx="2">
-            <a:schemeClr val="accent1">
-              <a:shade val="15000"/>
-            </a:schemeClr>
-          </a:lnRef>
-          <a:fillRef idx="1">
-            <a:schemeClr val="accent1"/>
-          </a:fillRef>
-          <a:effectRef idx="0">
-            <a:schemeClr val="accent1"/>
-          </a:effectRef>
-          <a:fontRef idx="minor">
-            <a:schemeClr val="lt1"/>
-          </a:fontRef>
-        </p:style>
-        <p:txBody>
-          <a:bodyPr rtlCol="0" anchor="ctr"/>
-          <a:lstStyle/>
-          <a:p>
-            <a:pPr algn="ctr"/>
-            <a:endParaRPr lang="en-US"/>
-          </a:p>
-        </p:txBody>
-      </p:sp>
-      <p:sp>
-        <p:nvSpPr>
-          <p:cNvPr id="41" name="Rounded Rectangle 40">
-            <a:extLst>
-              <a:ext uri="{FF2B5EF4-FFF2-40B4-BE49-F238E27FC236}">
-                <a16:creationId xmlns:a16="http://schemas.microsoft.com/office/drawing/2014/main" id="{F06BDB93-78C7-8D76-6132-59B3E256B355}"/>
-              </a:ext>
-            </a:extLst>
-          </p:cNvPr>
-          <p:cNvSpPr/>
-          <p:nvPr/>
-        </p:nvSpPr>
-        <p:spPr>
-          <a:xfrm>
-            <a:off x="6929614" y="3771628"/>
-            <a:ext cx="6403360" cy="3354378"/>
-          </a:xfrm>
-          <a:prstGeom prst="roundRect">
-            <a:avLst>
-              <a:gd name="adj" fmla="val 2687"/>
-            </a:avLst>
-          </a:prstGeom>
-          <a:solidFill>
-            <a:schemeClr val="bg1">
-              <a:alpha val="44716"/>
-            </a:schemeClr>
-          </a:solidFill>
-          <a:ln w="0">
-            <a:solidFill>
-              <a:schemeClr val="bg1">
-                <a:lumMod val="75000"/>
-              </a:schemeClr>
-            </a:solidFill>
-          </a:ln>
-        </p:spPr>
-        <p:style>
-          <a:lnRef idx="2">
-            <a:schemeClr val="accent1">
-              <a:shade val="15000"/>
-            </a:schemeClr>
-          </a:lnRef>
-          <a:fillRef idx="1">
-            <a:schemeClr val="accent1"/>
-          </a:fillRef>
-          <a:effectRef idx="0">
-            <a:schemeClr val="accent1"/>
-          </a:effectRef>
-          <a:fontRef idx="minor">
-            <a:schemeClr val="lt1"/>
-          </a:fontRef>
-        </p:style>
-        <p:txBody>
-          <a:bodyPr rtlCol="0" anchor="ctr"/>
-          <a:lstStyle/>
-          <a:p>
-            <a:pPr algn="ctr"/>
-            <a:endParaRPr lang="en-US"/>
-          </a:p>
-        </p:txBody>
-      </p:sp>
-      <p:sp>
-        <p:nvSpPr>
-          <p:cNvPr id="42" name="Rounded Rectangle 41">
-            <a:extLst>
-              <a:ext uri="{FF2B5EF4-FFF2-40B4-BE49-F238E27FC236}">
-                <a16:creationId xmlns:a16="http://schemas.microsoft.com/office/drawing/2014/main" id="{9255D72B-5FBF-F6C5-B274-0A63C84E2EDC}"/>
-              </a:ext>
-            </a:extLst>
-          </p:cNvPr>
-          <p:cNvSpPr/>
-          <p:nvPr/>
-        </p:nvSpPr>
-        <p:spPr>
-          <a:xfrm>
-            <a:off x="6929614" y="7243491"/>
-            <a:ext cx="6403360" cy="2901026"/>
-          </a:xfrm>
-          <a:prstGeom prst="roundRect">
-            <a:avLst>
-              <a:gd name="adj" fmla="val 4817"/>
-            </a:avLst>
-          </a:prstGeom>
-          <a:solidFill>
-            <a:schemeClr val="bg1">
-              <a:alpha val="44716"/>
-            </a:schemeClr>
-          </a:solidFill>
-          <a:ln w="0">
-            <a:solidFill>
-              <a:schemeClr val="bg1">
-                <a:lumMod val="75000"/>
-              </a:schemeClr>
-            </a:solidFill>
-          </a:ln>
-        </p:spPr>
-        <p:style>
-          <a:lnRef idx="2">
-            <a:schemeClr val="accent1">
-              <a:shade val="15000"/>
-            </a:schemeClr>
-          </a:lnRef>
-          <a:fillRef idx="1">
-            <a:schemeClr val="accent1"/>
-          </a:fillRef>
-          <a:effectRef idx="0">
-            <a:schemeClr val="accent1"/>
-          </a:effectRef>
-          <a:fontRef idx="minor">
-            <a:schemeClr val="lt1"/>
-          </a:fontRef>
-        </p:style>
-        <p:txBody>
-          <a:bodyPr rtlCol="0" anchor="ctr"/>
-          <a:lstStyle/>
-          <a:p>
-            <a:pPr algn="ctr"/>
-            <a:endParaRPr lang="en-US"/>
-          </a:p>
-        </p:txBody>
-      </p:sp>
-      <p:sp>
-        <p:nvSpPr>
-          <p:cNvPr id="43" name="Rounded Rectangle 42">
-            <a:extLst>
-              <a:ext uri="{FF2B5EF4-FFF2-40B4-BE49-F238E27FC236}">
-                <a16:creationId xmlns:a16="http://schemas.microsoft.com/office/drawing/2014/main" id="{C1CE83DB-D956-AE2C-F35D-380A56600C5A}"/>
-              </a:ext>
-            </a:extLst>
-          </p:cNvPr>
-          <p:cNvSpPr/>
-          <p:nvPr/>
-        </p:nvSpPr>
-        <p:spPr>
-          <a:xfrm>
-            <a:off x="13616159" y="3771628"/>
-            <a:ext cx="4487994" cy="3354378"/>
-          </a:xfrm>
-          <a:prstGeom prst="roundRect">
-            <a:avLst>
-              <a:gd name="adj" fmla="val 3539"/>
-            </a:avLst>
-          </a:prstGeom>
-          <a:solidFill>
-            <a:schemeClr val="bg1">
-              <a:alpha val="44716"/>
-            </a:schemeClr>
-          </a:solidFill>
-          <a:ln w="0">
-            <a:solidFill>
-              <a:schemeClr val="bg1">
-                <a:lumMod val="75000"/>
-              </a:schemeClr>
-            </a:solidFill>
-          </a:ln>
-        </p:spPr>
-        <p:style>
-          <a:lnRef idx="2">
-            <a:schemeClr val="accent1">
-              <a:shade val="15000"/>
-            </a:schemeClr>
-          </a:lnRef>
-          <a:fillRef idx="1">
-            <a:schemeClr val="accent1"/>
-          </a:fillRef>
-          <a:effectRef idx="0">
-            <a:schemeClr val="accent1"/>
-          </a:effectRef>
-          <a:fontRef idx="minor">
-            <a:schemeClr val="lt1"/>
-          </a:fontRef>
-        </p:style>
-        <p:txBody>
-          <a:bodyPr rtlCol="0" anchor="ctr"/>
-          <a:lstStyle/>
-          <a:p>
-            <a:pPr algn="ctr"/>
-            <a:endParaRPr lang="en-US"/>
-          </a:p>
-        </p:txBody>
-      </p:sp>
-      <p:sp>
-        <p:nvSpPr>
-          <p:cNvPr id="44" name="Rounded Rectangle 43">
-            <a:extLst>
-              <a:ext uri="{FF2B5EF4-FFF2-40B4-BE49-F238E27FC236}">
-                <a16:creationId xmlns:a16="http://schemas.microsoft.com/office/drawing/2014/main" id="{00FE0E00-A66B-FFD4-5861-7481F872346C}"/>
-              </a:ext>
-            </a:extLst>
-          </p:cNvPr>
-          <p:cNvSpPr/>
-          <p:nvPr/>
-        </p:nvSpPr>
-        <p:spPr>
-          <a:xfrm>
-            <a:off x="13616159" y="885553"/>
-            <a:ext cx="4487994" cy="2757760"/>
-          </a:xfrm>
-          <a:prstGeom prst="roundRect">
-            <a:avLst>
-              <a:gd name="adj" fmla="val 4817"/>
-            </a:avLst>
-          </a:prstGeom>
-          <a:solidFill>
-            <a:schemeClr val="bg1">
-              <a:alpha val="44716"/>
-            </a:schemeClr>
-          </a:solidFill>
-          <a:ln w="0">
-            <a:solidFill>
-              <a:schemeClr val="bg1">
-                <a:lumMod val="75000"/>
-              </a:schemeClr>
-            </a:solidFill>
-          </a:ln>
-        </p:spPr>
-        <p:style>
-          <a:lnRef idx="2">
-            <a:schemeClr val="accent1">
-              <a:shade val="15000"/>
-            </a:schemeClr>
-          </a:lnRef>
-          <a:fillRef idx="1">
-            <a:schemeClr val="accent1"/>
-          </a:fillRef>
-          <a:effectRef idx="0">
-            <a:schemeClr val="accent1"/>
-          </a:effectRef>
-          <a:fontRef idx="minor">
-            <a:schemeClr val="lt1"/>
-          </a:fontRef>
-        </p:style>
-        <p:txBody>
-          <a:bodyPr rtlCol="0" anchor="ctr"/>
-          <a:lstStyle/>
-          <a:p>
-            <a:pPr algn="ctr"/>
-            <a:endParaRPr lang="en-US"/>
-          </a:p>
-        </p:txBody>
-      </p:sp>
       <p:sp>
         <p:nvSpPr>
           <p:cNvPr id="3" name="Subtitle 2"/>
@@ -1080,15 +546,28 @@
               <a:buNone/>
             </a:pPr>
             <a:r>
-              <a:rPr lang="en-US" sz="2800" dirty="0">
-                <a:latin typeface="Montserrat" pitchFamily="2" charset="77"/>
+              <a:rPr lang="en-US" sz="2200" dirty="0">
+                <a:solidFill>
+                  <a:schemeClr val="tx1">
+                    <a:lumMod val="65000"/>
+                    <a:lumOff val="35000"/>
+                  </a:schemeClr>
+                </a:solidFill>
+                <a:latin typeface="Arial" panose="020B0604020202020204" pitchFamily="34" charset="0"/>
                 <a:ea typeface="+mn-lt"/>
-                <a:cs typeface="+mn-lt"/>
+                <a:cs typeface="Arial" panose="020B0604020202020204" pitchFamily="34" charset="0"/>
               </a:rPr>
               <a:t>{{BUSINESS_NAME}}</a:t>
             </a:r>
-            <a:endParaRPr lang="en-US" sz="2800" dirty="0">
-              <a:latin typeface="Montserrat" pitchFamily="2" charset="77"/>
+            <a:endParaRPr lang="en-US" sz="2200" dirty="0">
+              <a:solidFill>
+                <a:schemeClr val="tx1">
+                  <a:lumMod val="65000"/>
+                  <a:lumOff val="35000"/>
+                </a:schemeClr>
+              </a:solidFill>
+              <a:latin typeface="Arial" panose="020B0604020202020204" pitchFamily="34" charset="0"/>
+              <a:cs typeface="Arial" panose="020B0604020202020204" pitchFamily="34" charset="0"/>
             </a:endParaRPr>
           </a:p>
         </p:txBody>
@@ -1109,7 +588,7 @@
         </p:nvSpPr>
         <p:spPr>
           <a:xfrm>
-            <a:off x="13651681" y="3909409"/>
+            <a:off x="13651681" y="2090282"/>
             <a:ext cx="4395108" cy="557348"/>
           </a:xfrm>
           <a:prstGeom prst="rect">
@@ -1291,15 +770,22 @@
               </a:spcBef>
             </a:pPr>
             <a:r>
-              <a:rPr lang="en-US" sz="1800" dirty="0">
-                <a:latin typeface="Montserrat SemiBold" pitchFamily="2" charset="77"/>
+              <a:rPr lang="en-US" sz="1600" dirty="0">
+                <a:solidFill>
+                  <a:srgbClr val="E77429"/>
+                </a:solidFill>
+                <a:latin typeface="Arial" panose="020B0604020202020204" pitchFamily="34" charset="0"/>
                 <a:ea typeface="+mn-lt"/>
-                <a:cs typeface="+mn-lt"/>
+                <a:cs typeface="Arial" panose="020B0604020202020204" pitchFamily="34" charset="0"/>
               </a:rPr>
               <a:t>{{DREAMH}}</a:t>
             </a:r>
-            <a:endParaRPr lang="en-US" sz="1800" dirty="0">
-              <a:latin typeface="Montserrat SemiBold" pitchFamily="2" charset="77"/>
+            <a:endParaRPr lang="en-US" sz="1600" dirty="0">
+              <a:solidFill>
+                <a:srgbClr val="E77429"/>
+              </a:solidFill>
+              <a:latin typeface="Arial" panose="020B0604020202020204" pitchFamily="34" charset="0"/>
+              <a:cs typeface="Arial" panose="020B0604020202020204" pitchFamily="34" charset="0"/>
             </a:endParaRPr>
           </a:p>
         </p:txBody>
@@ -1320,8 +806,8 @@
         </p:nvSpPr>
         <p:spPr>
           <a:xfrm>
-            <a:off x="13651682" y="996942"/>
-            <a:ext cx="4395107" cy="517071"/>
+            <a:off x="13651682" y="5659659"/>
+            <a:ext cx="4395107" cy="517072"/>
           </a:xfrm>
           <a:prstGeom prst="rect">
             <a:avLst/>
@@ -1502,15 +988,22 @@
               </a:spcBef>
             </a:pPr>
             <a:r>
-              <a:rPr lang="en-US" sz="1800" dirty="0">
-                <a:latin typeface="Montserrat SemiBold" pitchFamily="2" charset="77"/>
+              <a:rPr lang="en-US" sz="1600" dirty="0">
+                <a:solidFill>
+                  <a:srgbClr val="E77429"/>
+                </a:solidFill>
+                <a:latin typeface="Arial" panose="020B0604020202020204" pitchFamily="34" charset="0"/>
                 <a:ea typeface="+mn-lt"/>
-                <a:cs typeface="+mn-lt"/>
+                <a:cs typeface="Arial" panose="020B0604020202020204" pitchFamily="34" charset="0"/>
               </a:rPr>
               <a:t>{{PURPOSEH}}</a:t>
             </a:r>
-            <a:endParaRPr lang="en-US" sz="1800" dirty="0">
-              <a:latin typeface="Montserrat SemiBold" pitchFamily="2" charset="77"/>
+            <a:endParaRPr lang="en-US" sz="1600" dirty="0">
+              <a:solidFill>
+                <a:srgbClr val="E77429"/>
+              </a:solidFill>
+              <a:latin typeface="Arial" panose="020B0604020202020204" pitchFamily="34" charset="0"/>
+              <a:cs typeface="Arial" panose="020B0604020202020204" pitchFamily="34" charset="0"/>
             </a:endParaRPr>
           </a:p>
         </p:txBody>
@@ -1531,8 +1024,8 @@
         </p:nvSpPr>
         <p:spPr>
           <a:xfrm>
-            <a:off x="337456" y="923584"/>
-            <a:ext cx="12913169" cy="1136535"/>
+            <a:off x="337456" y="890132"/>
+            <a:ext cx="17337227" cy="969040"/>
           </a:xfrm>
           <a:prstGeom prst="rect">
             <a:avLst/>
@@ -1717,15 +1210,27 @@
             </a:pPr>
             <a:r>
               <a:rPr lang="en-US" sz="1400" b="1" dirty="0">
-                <a:latin typeface="Montserrat SemiBold" pitchFamily="2" charset="77"/>
+                <a:solidFill>
+                  <a:schemeClr val="tx1">
+                    <a:lumMod val="65000"/>
+                    <a:lumOff val="35000"/>
+                  </a:schemeClr>
+                </a:solidFill>
+                <a:latin typeface="Arial" panose="020B0604020202020204" pitchFamily="34" charset="0"/>
                 <a:ea typeface="+mn-lt"/>
-                <a:cs typeface="+mn-lt"/>
+                <a:cs typeface="Arial" panose="020B0604020202020204" pitchFamily="34" charset="0"/>
               </a:rPr>
               <a:t>{{BIG_WHY}}</a:t>
             </a:r>
             <a:endParaRPr lang="en-US" sz="1400" b="1" dirty="0">
-              <a:latin typeface="Montserrat SemiBold" pitchFamily="2" charset="77"/>
-              <a:cs typeface="Arial"/>
+              <a:solidFill>
+                <a:schemeClr val="tx1">
+                  <a:lumMod val="65000"/>
+                  <a:lumOff val="35000"/>
+                </a:schemeClr>
+              </a:solidFill>
+              <a:latin typeface="Arial" panose="020B0604020202020204" pitchFamily="34" charset="0"/>
+              <a:cs typeface="Arial" panose="020B0604020202020204" pitchFamily="34" charset="0"/>
             </a:endParaRPr>
           </a:p>
         </p:txBody>
@@ -1746,8 +1251,8 @@
         </p:nvSpPr>
         <p:spPr>
           <a:xfrm>
-            <a:off x="13651682" y="1328270"/>
-            <a:ext cx="4395108" cy="1440865"/>
+            <a:off x="13651682" y="5990988"/>
+            <a:ext cx="4395108" cy="2618288"/>
           </a:xfrm>
           <a:prstGeom prst="rect">
             <a:avLst/>
@@ -1924,23 +1429,35 @@
           <a:p>
             <a:pPr algn="l">
               <a:lnSpc>
-                <a:spcPts val="2400"/>
+                <a:spcPts val="1640"/>
               </a:lnSpc>
               <a:spcBef>
                 <a:spcPts val="0"/>
               </a:spcBef>
             </a:pPr>
             <a:r>
-              <a:rPr lang="en-US" sz="1400" dirty="0">
-                <a:latin typeface="Montserrat" pitchFamily="2" charset="77"/>
+              <a:rPr lang="en-US" sz="1200" dirty="0">
+                <a:solidFill>
+                  <a:schemeClr val="tx1">
+                    <a:lumMod val="65000"/>
+                    <a:lumOff val="35000"/>
+                  </a:schemeClr>
+                </a:solidFill>
+                <a:latin typeface="Arial" panose="020B0604020202020204" pitchFamily="34" charset="0"/>
                 <a:ea typeface="+mn-lt"/>
-                <a:cs typeface="+mn-lt"/>
+                <a:cs typeface="Arial" panose="020B0604020202020204" pitchFamily="34" charset="0"/>
               </a:rPr>
               <a:t>{{PURPOSE}}</a:t>
             </a:r>
-            <a:endParaRPr lang="en-US" sz="1400" dirty="0">
-              <a:latin typeface="Montserrat" pitchFamily="2" charset="77"/>
-              <a:cs typeface="Arial"/>
+            <a:endParaRPr lang="en-US" sz="1200" dirty="0">
+              <a:solidFill>
+                <a:schemeClr val="tx1">
+                  <a:lumMod val="65000"/>
+                  <a:lumOff val="35000"/>
+                </a:schemeClr>
+              </a:solidFill>
+              <a:latin typeface="Arial" panose="020B0604020202020204" pitchFamily="34" charset="0"/>
+              <a:cs typeface="Arial" panose="020B0604020202020204" pitchFamily="34" charset="0"/>
             </a:endParaRPr>
           </a:p>
         </p:txBody>
@@ -1961,8 +1478,8 @@
         </p:nvSpPr>
         <p:spPr>
           <a:xfrm>
-            <a:off x="13651681" y="4213522"/>
-            <a:ext cx="4395108" cy="3724877"/>
+            <a:off x="13651681" y="2394395"/>
+            <a:ext cx="4395108" cy="3000275"/>
           </a:xfrm>
           <a:prstGeom prst="rect">
             <a:avLst/>
@@ -2139,23 +1656,35 @@
           <a:p>
             <a:pPr algn="l">
               <a:lnSpc>
-                <a:spcPts val="2400"/>
+                <a:spcPts val="1640"/>
               </a:lnSpc>
               <a:spcBef>
                 <a:spcPts val="0"/>
               </a:spcBef>
             </a:pPr>
             <a:r>
-              <a:rPr lang="en-US" sz="1400" dirty="0">
-                <a:latin typeface="Montserrat" pitchFamily="2" charset="77"/>
+              <a:rPr lang="en-US" sz="1200" dirty="0">
+                <a:solidFill>
+                  <a:schemeClr val="tx1">
+                    <a:lumMod val="65000"/>
+                    <a:lumOff val="35000"/>
+                  </a:schemeClr>
+                </a:solidFill>
+                <a:latin typeface="Arial" panose="020B0604020202020204" pitchFamily="34" charset="0"/>
                 <a:ea typeface="+mn-lt"/>
-                <a:cs typeface="+mn-lt"/>
+                <a:cs typeface="Arial" panose="020B0604020202020204" pitchFamily="34" charset="0"/>
               </a:rPr>
-              <a:t>{{DREAM}}</a:t>
+              <a:t>{{DREAM}</a:t>
             </a:r>
-            <a:endParaRPr lang="en-US" sz="1400" dirty="0">
-              <a:latin typeface="Montserrat" pitchFamily="2" charset="77"/>
-              <a:cs typeface="Arial"/>
+            <a:endParaRPr lang="en-US" sz="1200" dirty="0">
+              <a:solidFill>
+                <a:schemeClr val="tx1">
+                  <a:lumMod val="65000"/>
+                  <a:lumOff val="35000"/>
+                </a:schemeClr>
+              </a:solidFill>
+              <a:latin typeface="Arial" panose="020B0604020202020204" pitchFamily="34" charset="0"/>
+              <a:cs typeface="Arial" panose="020B0604020202020204" pitchFamily="34" charset="0"/>
             </a:endParaRPr>
           </a:p>
         </p:txBody>
@@ -2176,7 +1705,7 @@
         </p:nvSpPr>
         <p:spPr>
           <a:xfrm>
-            <a:off x="337453" y="3909409"/>
+            <a:off x="337453" y="2067834"/>
             <a:ext cx="6164035" cy="497003"/>
           </a:xfrm>
           <a:prstGeom prst="rect">
@@ -2358,10 +1887,13 @@
               </a:spcBef>
             </a:pPr>
             <a:r>
-              <a:rPr lang="en-US" sz="1800" b="1" dirty="0">
-                <a:latin typeface="Montserrat SemiBold" pitchFamily="2" charset="77"/>
+              <a:rPr lang="en-US" sz="1600" dirty="0">
+                <a:solidFill>
+                  <a:srgbClr val="E77429"/>
+                </a:solidFill>
+                <a:latin typeface="Arial" panose="020B0604020202020204" pitchFamily="34" charset="0"/>
                 <a:ea typeface="+mn-lt"/>
-                <a:cs typeface="+mn-lt"/>
+                <a:cs typeface="Arial" panose="020B0604020202020204" pitchFamily="34" charset="0"/>
               </a:rPr>
               <a:t>{{ROLEH}}</a:t>
             </a:r>
@@ -2384,8 +1916,8 @@
         </p:nvSpPr>
         <p:spPr>
           <a:xfrm>
-            <a:off x="337452" y="4213522"/>
-            <a:ext cx="6164036" cy="888611"/>
+            <a:off x="337452" y="2371947"/>
+            <a:ext cx="6164036" cy="1473316"/>
           </a:xfrm>
           <a:prstGeom prst="rect">
             <a:avLst/>
@@ -2562,17 +2094,23 @@
           <a:p>
             <a:pPr algn="l">
               <a:lnSpc>
-                <a:spcPts val="2400"/>
+                <a:spcPts val="1640"/>
               </a:lnSpc>
               <a:spcBef>
                 <a:spcPts val="0"/>
               </a:spcBef>
             </a:pPr>
             <a:r>
-              <a:rPr lang="en-US" sz="1400" dirty="0">
-                <a:latin typeface="Montserrat" pitchFamily="2" charset="77"/>
+              <a:rPr lang="en-US" sz="1200" dirty="0">
+                <a:solidFill>
+                  <a:schemeClr val="tx1">
+                    <a:lumMod val="65000"/>
+                    <a:lumOff val="35000"/>
+                  </a:schemeClr>
+                </a:solidFill>
+                <a:latin typeface="Arial" panose="020B0604020202020204" pitchFamily="34" charset="0"/>
                 <a:ea typeface="+mn-lt"/>
-                <a:cs typeface="+mn-lt"/>
+                <a:cs typeface="Arial" panose="020B0604020202020204" pitchFamily="34" charset="0"/>
               </a:rPr>
               <a:t>{{ROLE}}</a:t>
             </a:r>
@@ -2595,7 +2133,7 @@
         </p:nvSpPr>
         <p:spPr>
           <a:xfrm>
-            <a:off x="337452" y="5257941"/>
+            <a:off x="337452" y="4091633"/>
             <a:ext cx="6164036" cy="497003"/>
           </a:xfrm>
           <a:prstGeom prst="rect">
@@ -2777,10 +2315,13 @@
               </a:spcBef>
             </a:pPr>
             <a:r>
-              <a:rPr lang="en-US" sz="1800" b="1" dirty="0">
-                <a:latin typeface="Montserrat SemiBold" pitchFamily="2" charset="77"/>
+              <a:rPr lang="en-US" sz="1600" dirty="0">
+                <a:solidFill>
+                  <a:srgbClr val="E77429"/>
+                </a:solidFill>
+                <a:latin typeface="Arial" panose="020B0604020202020204" pitchFamily="34" charset="0"/>
                 <a:ea typeface="+mn-lt"/>
-                <a:cs typeface="+mn-lt"/>
+                <a:cs typeface="Arial" panose="020B0604020202020204" pitchFamily="34" charset="0"/>
               </a:rPr>
               <a:t>{{ENTITYH}}</a:t>
             </a:r>
@@ -2803,8 +2344,8 @@
         </p:nvSpPr>
         <p:spPr>
           <a:xfrm>
-            <a:off x="337450" y="5562055"/>
-            <a:ext cx="6164035" cy="547770"/>
+            <a:off x="337450" y="4395746"/>
+            <a:ext cx="6164035" cy="998925"/>
           </a:xfrm>
           <a:prstGeom prst="rect">
             <a:avLst/>
@@ -2981,32 +2522,26 @@
           <a:p>
             <a:pPr algn="l">
               <a:lnSpc>
-                <a:spcPts val="2400"/>
+                <a:spcPts val="1640"/>
               </a:lnSpc>
               <a:spcBef>
                 <a:spcPts val="0"/>
               </a:spcBef>
             </a:pPr>
             <a:r>
-              <a:rPr lang="en-US" sz="1400" dirty="0">
-                <a:latin typeface="Montserrat" pitchFamily="2" charset="77"/>
+              <a:rPr lang="en-US" sz="1200" dirty="0">
+                <a:solidFill>
+                  <a:schemeClr val="tx1">
+                    <a:lumMod val="65000"/>
+                    <a:lumOff val="35000"/>
+                  </a:schemeClr>
+                </a:solidFill>
+                <a:latin typeface="Arial" panose="020B0604020202020204" pitchFamily="34" charset="0"/>
                 <a:ea typeface="+mn-lt"/>
-                <a:cs typeface="+mn-lt"/>
+                <a:cs typeface="Arial" panose="020B0604020202020204" pitchFamily="34" charset="0"/>
               </a:rPr>
               <a:t>{{ENTITY}}</a:t>
             </a:r>
-            <a:br>
-              <a:rPr lang="en-US" sz="1400" dirty="0">
-                <a:latin typeface="Montserrat" pitchFamily="2" charset="77"/>
-                <a:ea typeface="+mn-lt"/>
-                <a:cs typeface="+mn-lt"/>
-              </a:rPr>
-            </a:br>
-            <a:endParaRPr lang="en-US" sz="1400" dirty="0">
-              <a:latin typeface="Montserrat" pitchFamily="2" charset="77"/>
-              <a:ea typeface="+mn-lt"/>
-              <a:cs typeface="+mn-lt"/>
-            </a:endParaRPr>
           </a:p>
         </p:txBody>
       </p:sp>
@@ -3026,7 +2561,7 @@
         </p:nvSpPr>
         <p:spPr>
           <a:xfrm>
-            <a:off x="6932152" y="3909409"/>
+            <a:off x="6932152" y="4079713"/>
             <a:ext cx="6164033" cy="497003"/>
           </a:xfrm>
           <a:prstGeom prst="rect">
@@ -3208,10 +2743,13 @@
               </a:spcBef>
             </a:pPr>
             <a:r>
-              <a:rPr lang="en-US" sz="1800" b="1" dirty="0">
-                <a:latin typeface="Montserrat SemiBold" pitchFamily="2" charset="77"/>
+              <a:rPr lang="en-US" sz="1600" dirty="0">
+                <a:solidFill>
+                  <a:srgbClr val="E77429"/>
+                </a:solidFill>
+                <a:latin typeface="Arial" panose="020B0604020202020204" pitchFamily="34" charset="0"/>
                 <a:ea typeface="+mn-lt"/>
-                <a:cs typeface="+mn-lt"/>
+                <a:cs typeface="Arial" panose="020B0604020202020204" pitchFamily="34" charset="0"/>
               </a:rPr>
               <a:t>{{STRATEGYH}}</a:t>
             </a:r>
@@ -3234,8 +2772,8 @@
         </p:nvSpPr>
         <p:spPr>
           <a:xfrm>
-            <a:off x="6932152" y="4213522"/>
-            <a:ext cx="6164036" cy="3155616"/>
+            <a:off x="6932152" y="4383826"/>
+            <a:ext cx="6164036" cy="2618288"/>
           </a:xfrm>
           <a:prstGeom prst="rect">
             <a:avLst/>
@@ -3410,20 +2948,29 @@
             </a:lvl9pPr>
           </a:lstStyle>
           <a:p>
-            <a:pPr marL="257175" indent="-257175" algn="l">
-              <a:lnSpc>
-                <a:spcPts val="2400"/>
+            <a:pPr marL="171450" indent="-160338" algn="l">
+              <a:lnSpc>
+                <a:spcPts val="1640"/>
               </a:lnSpc>
               <a:spcBef>
                 <a:spcPts val="0"/>
               </a:spcBef>
+              <a:buClr>
+                <a:srgbClr val="E77429"/>
+              </a:buClr>
               <a:buChar char="•"/>
             </a:pPr>
             <a:r>
-              <a:rPr lang="en-US" sz="1400" dirty="0">
-                <a:latin typeface="Montserrat" pitchFamily="2" charset="77"/>
+              <a:rPr lang="en-US" sz="1200" dirty="0">
+                <a:solidFill>
+                  <a:schemeClr val="tx1">
+                    <a:lumMod val="65000"/>
+                    <a:lumOff val="35000"/>
+                  </a:schemeClr>
+                </a:solidFill>
+                <a:latin typeface="Arial" panose="020B0604020202020204" pitchFamily="34" charset="0"/>
                 <a:ea typeface="+mn-lt"/>
-                <a:cs typeface="+mn-lt"/>
+                <a:cs typeface="Arial" panose="020B0604020202020204" pitchFamily="34" charset="0"/>
               </a:rPr>
               <a:t>{{STRATEGY}}</a:t>
             </a:r>
@@ -3446,7 +2993,7 @@
         </p:nvSpPr>
         <p:spPr>
           <a:xfrm>
-            <a:off x="337450" y="6353597"/>
+            <a:off x="337450" y="5641041"/>
             <a:ext cx="6164035" cy="497003"/>
           </a:xfrm>
           <a:prstGeom prst="rect">
@@ -3628,10 +3175,13 @@
               </a:spcBef>
             </a:pPr>
             <a:r>
-              <a:rPr lang="en-US" sz="1800" b="1" dirty="0">
-                <a:latin typeface="Montserrat SemiBold" pitchFamily="2" charset="77"/>
+              <a:rPr lang="en-US" sz="1600" dirty="0">
+                <a:solidFill>
+                  <a:srgbClr val="E77429"/>
+                </a:solidFill>
+                <a:latin typeface="Arial" panose="020B0604020202020204" pitchFamily="34" charset="0"/>
                 <a:ea typeface="+mn-lt"/>
-                <a:cs typeface="+mn-lt"/>
+                <a:cs typeface="Arial" panose="020B0604020202020204" pitchFamily="34" charset="0"/>
               </a:rPr>
               <a:t>{{TARGET_GROUPH}}</a:t>
             </a:r>
@@ -3654,8 +3204,8 @@
         </p:nvSpPr>
         <p:spPr>
           <a:xfrm>
-            <a:off x="337450" y="6657711"/>
-            <a:ext cx="6164034" cy="539325"/>
+            <a:off x="337450" y="5945155"/>
+            <a:ext cx="6164034" cy="1095691"/>
           </a:xfrm>
           <a:prstGeom prst="rect">
             <a:avLst/>
@@ -3832,31 +3382,49 @@
           <a:p>
             <a:pPr algn="l">
               <a:lnSpc>
-                <a:spcPts val="2400"/>
+                <a:spcPts val="1640"/>
               </a:lnSpc>
               <a:spcBef>
                 <a:spcPts val="0"/>
               </a:spcBef>
             </a:pPr>
             <a:r>
-              <a:rPr lang="en-US" sz="1400" dirty="0">
-                <a:latin typeface="Montserrat" pitchFamily="2" charset="77"/>
+              <a:rPr lang="en-US" sz="1200" dirty="0">
+                <a:solidFill>
+                  <a:schemeClr val="tx1">
+                    <a:lumMod val="65000"/>
+                    <a:lumOff val="35000"/>
+                  </a:schemeClr>
+                </a:solidFill>
+                <a:latin typeface="Arial" panose="020B0604020202020204" pitchFamily="34" charset="0"/>
                 <a:ea typeface="+mn-lt"/>
-                <a:cs typeface="+mn-lt"/>
+                <a:cs typeface="Arial" panose="020B0604020202020204" pitchFamily="34" charset="0"/>
               </a:rPr>
               <a:t>{{TARGET_GROUP}}</a:t>
             </a:r>
             <a:br>
-              <a:rPr lang="en-US" sz="1400" dirty="0">
-                <a:latin typeface="Montserrat" pitchFamily="2" charset="77"/>
+              <a:rPr lang="en-US" sz="1200" dirty="0">
+                <a:solidFill>
+                  <a:schemeClr val="tx1">
+                    <a:lumMod val="65000"/>
+                    <a:lumOff val="35000"/>
+                  </a:schemeClr>
+                </a:solidFill>
+                <a:latin typeface="Arial" panose="020B0604020202020204" pitchFamily="34" charset="0"/>
                 <a:ea typeface="+mn-lt"/>
-                <a:cs typeface="+mn-lt"/>
+                <a:cs typeface="Arial" panose="020B0604020202020204" pitchFamily="34" charset="0"/>
               </a:rPr>
             </a:br>
-            <a:endParaRPr lang="en-US" sz="1400" dirty="0">
-              <a:latin typeface="Montserrat" pitchFamily="2" charset="77"/>
+            <a:endParaRPr lang="en-US" sz="1200" dirty="0">
+              <a:solidFill>
+                <a:schemeClr val="tx1">
+                  <a:lumMod val="65000"/>
+                  <a:lumOff val="35000"/>
+                </a:schemeClr>
+              </a:solidFill>
+              <a:latin typeface="Arial" panose="020B0604020202020204" pitchFamily="34" charset="0"/>
               <a:ea typeface="+mn-lt"/>
-              <a:cs typeface="+mn-lt"/>
+              <a:cs typeface="Arial" panose="020B0604020202020204" pitchFamily="34" charset="0"/>
             </a:endParaRPr>
           </a:p>
         </p:txBody>
@@ -3877,7 +3445,7 @@
         </p:nvSpPr>
         <p:spPr>
           <a:xfrm>
-            <a:off x="337450" y="7447894"/>
+            <a:off x="337450" y="7271957"/>
             <a:ext cx="6164034" cy="497003"/>
           </a:xfrm>
           <a:prstGeom prst="rect">
@@ -4059,10 +3627,13 @@
               </a:spcBef>
             </a:pPr>
             <a:r>
-              <a:rPr lang="en-US" sz="1800" b="1" dirty="0">
-                <a:latin typeface="Montserrat SemiBold" pitchFamily="2" charset="77"/>
+              <a:rPr lang="en-US" sz="1600" dirty="0">
+                <a:solidFill>
+                  <a:srgbClr val="E77429"/>
+                </a:solidFill>
+                <a:latin typeface="Arial" panose="020B0604020202020204" pitchFamily="34" charset="0"/>
                 <a:ea typeface="+mn-lt"/>
-                <a:cs typeface="+mn-lt"/>
+                <a:cs typeface="Arial" panose="020B0604020202020204" pitchFamily="34" charset="0"/>
               </a:rPr>
               <a:t>{{PRODUCTS_SERVICESH}}</a:t>
             </a:r>
@@ -4085,8 +3656,8 @@
         </p:nvSpPr>
         <p:spPr>
           <a:xfrm>
-            <a:off x="337450" y="7752007"/>
-            <a:ext cx="6164034" cy="2392511"/>
+            <a:off x="337450" y="7576070"/>
+            <a:ext cx="6164034" cy="2618288"/>
           </a:xfrm>
           <a:prstGeom prst="rect">
             <a:avLst/>
@@ -4261,20 +3832,29 @@
             </a:lvl9pPr>
           </a:lstStyle>
           <a:p>
-            <a:pPr marL="257175" indent="-257175" algn="l">
-              <a:lnSpc>
-                <a:spcPts val="2400"/>
+            <a:pPr marL="158750" indent="-158750" algn="l">
+              <a:lnSpc>
+                <a:spcPts val="1640"/>
               </a:lnSpc>
               <a:spcBef>
                 <a:spcPts val="0"/>
               </a:spcBef>
+              <a:buClr>
+                <a:srgbClr val="E77429"/>
+              </a:buClr>
               <a:buChar char="•"/>
             </a:pPr>
             <a:r>
-              <a:rPr lang="en-US" sz="1400" dirty="0">
-                <a:latin typeface="Montserrat" pitchFamily="2" charset="77"/>
+              <a:rPr lang="en-US" sz="1200" dirty="0">
+                <a:solidFill>
+                  <a:schemeClr val="tx1">
+                    <a:lumMod val="65000"/>
+                    <a:lumOff val="35000"/>
+                  </a:schemeClr>
+                </a:solidFill>
+                <a:latin typeface="Arial" panose="020B0604020202020204" pitchFamily="34" charset="0"/>
                 <a:ea typeface="+mn-lt"/>
-                <a:cs typeface="+mn-lt"/>
+                <a:cs typeface="Arial" panose="020B0604020202020204" pitchFamily="34" charset="0"/>
               </a:rPr>
               <a:t>{{PRODUCTS_SERVICES}}</a:t>
             </a:r>
@@ -4297,7 +3877,7 @@
         </p:nvSpPr>
         <p:spPr>
           <a:xfrm>
-            <a:off x="6932152" y="7447894"/>
+            <a:off x="6932152" y="7271957"/>
             <a:ext cx="6164034" cy="497003"/>
           </a:xfrm>
           <a:prstGeom prst="rect">
@@ -4479,10 +4059,13 @@
               </a:spcBef>
             </a:pPr>
             <a:r>
-              <a:rPr lang="en-US" sz="1800" b="1" dirty="0">
-                <a:latin typeface="Montserrat SemiBold" pitchFamily="2" charset="77"/>
+              <a:rPr lang="en-US" sz="1600" dirty="0">
+                <a:solidFill>
+                  <a:srgbClr val="E77429"/>
+                </a:solidFill>
+                <a:latin typeface="Arial" panose="020B0604020202020204" pitchFamily="34" charset="0"/>
                 <a:ea typeface="+mn-lt"/>
-                <a:cs typeface="+mn-lt"/>
+                <a:cs typeface="Arial" panose="020B0604020202020204" pitchFamily="34" charset="0"/>
               </a:rPr>
               <a:t>{{RULES_OF_THE_GAMEH}}</a:t>
             </a:r>
@@ -4505,8 +4088,8 @@
         </p:nvSpPr>
         <p:spPr>
           <a:xfrm>
-            <a:off x="6932150" y="7752007"/>
-            <a:ext cx="6164036" cy="2178539"/>
+            <a:off x="6932150" y="7576070"/>
+            <a:ext cx="6164036" cy="2618288"/>
           </a:xfrm>
           <a:prstGeom prst="rect">
             <a:avLst/>
@@ -4681,25 +4264,41 @@
             </a:lvl9pPr>
           </a:lstStyle>
           <a:p>
-            <a:pPr marL="257175" indent="-257175" algn="l">
-              <a:lnSpc>
-                <a:spcPts val="2400"/>
+            <a:pPr marL="171450" indent="-160338" algn="l">
+              <a:lnSpc>
+                <a:spcPts val="1640"/>
               </a:lnSpc>
               <a:spcBef>
                 <a:spcPts val="0"/>
               </a:spcBef>
+              <a:buClr>
+                <a:srgbClr val="E77429"/>
+              </a:buClr>
               <a:buChar char="•"/>
             </a:pPr>
             <a:r>
-              <a:rPr lang="en-US" sz="1400" dirty="0">
-                <a:latin typeface="Montserrat" pitchFamily="2" charset="77"/>
+              <a:rPr lang="en-US" sz="1200" dirty="0">
+                <a:solidFill>
+                  <a:schemeClr val="tx1">
+                    <a:lumMod val="65000"/>
+                    <a:lumOff val="35000"/>
+                  </a:schemeClr>
+                </a:solidFill>
+                <a:latin typeface="Arial" panose="020B0604020202020204" pitchFamily="34" charset="0"/>
                 <a:ea typeface="+mn-lt"/>
-                <a:cs typeface="+mn-lt"/>
+                <a:cs typeface="Arial" panose="020B0604020202020204" pitchFamily="34" charset="0"/>
               </a:rPr>
               <a:t>{{RULES_OF_THE_GAME}}</a:t>
             </a:r>
-            <a:endParaRPr lang="en-US" sz="1400" dirty="0">
-              <a:latin typeface="Montserrat" pitchFamily="2" charset="77"/>
+            <a:endParaRPr lang="en-US" sz="1200" dirty="0">
+              <a:solidFill>
+                <a:schemeClr val="tx1">
+                  <a:lumMod val="65000"/>
+                  <a:lumOff val="35000"/>
+                </a:schemeClr>
+              </a:solidFill>
+              <a:latin typeface="Arial" panose="020B0604020202020204" pitchFamily="34" charset="0"/>
+              <a:cs typeface="Arial" panose="020B0604020202020204" pitchFamily="34" charset="0"/>
             </a:endParaRPr>
           </a:p>
         </p:txBody>
@@ -4900,24 +4499,14 @@
             <a:r>
               <a:rPr lang="en-US" sz="1200" dirty="0">
                 <a:solidFill>
-                  <a:srgbClr val="2B83E6"/>
-                </a:solidFill>
-                <a:latin typeface="Montserrat SemiBold" pitchFamily="2" charset="77"/>
+                  <a:srgbClr val="E77429"/>
+                </a:solidFill>
+                <a:latin typeface="Arial" panose="020B0604020202020204" pitchFamily="34" charset="0"/>
                 <a:ea typeface="+mn-lt"/>
-                <a:cs typeface="+mn-lt"/>
+                <a:cs typeface="Arial" panose="020B0604020202020204" pitchFamily="34" charset="0"/>
               </a:rPr>
               <a:t>Clarity comes from simplicity</a:t>
             </a:r>
-            <a:endParaRPr lang="en-US" sz="1200" dirty="0">
-              <a:solidFill>
-                <a:schemeClr val="bg1">
-                  <a:lumMod val="75000"/>
-                </a:schemeClr>
-              </a:solidFill>
-              <a:latin typeface="Montserrat" pitchFamily="2" charset="77"/>
-              <a:ea typeface="+mn-lt"/>
-              <a:cs typeface="+mn-lt"/>
-            </a:endParaRPr>
           </a:p>
           <a:p>
             <a:pPr algn="r"/>
@@ -4927,13 +4516,17 @@
                   <a:lumMod val="75000"/>
                 </a:schemeClr>
               </a:solidFill>
-              <a:latin typeface="Montserrat" pitchFamily="2" charset="77"/>
+              <a:latin typeface="Arial" panose="020B0604020202020204" pitchFamily="34" charset="0"/>
               <a:ea typeface="+mn-lt"/>
-              <a:cs typeface="+mn-lt"/>
+              <a:cs typeface="Arial" panose="020B0604020202020204" pitchFamily="34" charset="0"/>
             </a:endParaRPr>
           </a:p>
           <a:p>
-            <a:pPr algn="r"/>
+            <a:pPr algn="r">
+              <a:lnSpc>
+                <a:spcPts val="1640"/>
+              </a:lnSpc>
+            </a:pPr>
             <a:r>
               <a:rPr lang="en-US" sz="1200" dirty="0">
                 <a:solidFill>
@@ -4941,25 +4534,34 @@
                     <a:lumMod val="75000"/>
                   </a:schemeClr>
                 </a:solidFill>
-                <a:latin typeface="Montserrat" pitchFamily="2" charset="77"/>
+                <a:latin typeface="Arial" panose="020B0604020202020204" pitchFamily="34" charset="0"/>
                 <a:ea typeface="+mn-lt"/>
-                <a:cs typeface="+mn-lt"/>
+                <a:cs typeface="Arial" panose="020B0604020202020204" pitchFamily="34" charset="0"/>
               </a:rPr>
               <a:t>Business Canvas Strategy Builder _v1.01</a:t>
             </a:r>
-          </a:p>
-          <a:p>
-            <a:pPr algn="r"/>
-            <a:r>
+            <a:br>
               <a:rPr lang="en-US" sz="1200" dirty="0">
                 <a:solidFill>
                   <a:schemeClr val="bg1">
                     <a:lumMod val="75000"/>
                   </a:schemeClr>
                 </a:solidFill>
-                <a:latin typeface="Montserrat" pitchFamily="2" charset="77"/>
+                <a:latin typeface="Arial" panose="020B0604020202020204" pitchFamily="34" charset="0"/>
                 <a:ea typeface="+mn-lt"/>
-                <a:cs typeface="+mn-lt"/>
+                <a:cs typeface="Arial" panose="020B0604020202020204" pitchFamily="34" charset="0"/>
+              </a:rPr>
+            </a:br>
+            <a:r>
+              <a:rPr lang="en-US" sz="1200" dirty="0">
+                <a:solidFill>
+                  <a:schemeClr val="bg1">
+                    <a:lumMod val="75000"/>
+                  </a:schemeClr>
+                </a:solidFill>
+                <a:latin typeface="Arial" panose="020B0604020202020204" pitchFamily="34" charset="0"/>
+                <a:ea typeface="+mn-lt"/>
+                <a:cs typeface="Arial" panose="020B0604020202020204" pitchFamily="34" charset="0"/>
               </a:rPr>
               <a:t>A business model by </a:t>
             </a:r>
@@ -4970,10 +4572,10 @@
                     <a:lumMod val="75000"/>
                   </a:schemeClr>
                 </a:solidFill>
-                <a:latin typeface="Montserrat" pitchFamily="2" charset="77"/>
+                <a:latin typeface="Arial" panose="020B0604020202020204" pitchFamily="34" charset="0"/>
                 <a:ea typeface="+mn-lt"/>
-                <a:cs typeface="+mn-lt"/>
-                <a:hlinkClick r:id="rId4">
+                <a:cs typeface="Arial" panose="020B0604020202020204" pitchFamily="34" charset="0"/>
+                <a:hlinkClick r:id="rId3">
                   <a:extLst>
                     <a:ext uri="{A12FA001-AC4F-418D-AE19-62706E023703}">
                       <ahyp:hlinkClr xmlns:ahyp="http://schemas.microsoft.com/office/drawing/2018/hyperlinkcolor" val="tx"/>
@@ -4985,10 +4587,12 @@
             </a:r>
             <a:endParaRPr lang="en-US" sz="1200" dirty="0">
               <a:solidFill>
-                <a:srgbClr val="2B83E6"/>
+                <a:schemeClr val="bg1">
+                  <a:lumMod val="75000"/>
+                </a:schemeClr>
               </a:solidFill>
-              <a:latin typeface="Montserrat SemiBold" pitchFamily="2" charset="77"/>
-              <a:cs typeface="Arial"/>
+              <a:latin typeface="Arial" panose="020B0604020202020204" pitchFamily="34" charset="0"/>
+              <a:cs typeface="Arial" panose="020B0604020202020204" pitchFamily="34" charset="0"/>
             </a:endParaRPr>
           </a:p>
           <a:p>
@@ -4999,8 +4603,8 @@
                   <a:lumMod val="75000"/>
                 </a:schemeClr>
               </a:solidFill>
-              <a:latin typeface="Montserrat" pitchFamily="2" charset="77"/>
-              <a:cs typeface="Arial"/>
+              <a:latin typeface="Arial" panose="020B0604020202020204" pitchFamily="34" charset="0"/>
+              <a:cs typeface="Arial" panose="020B0604020202020204" pitchFamily="34" charset="0"/>
             </a:endParaRPr>
           </a:p>
         </p:txBody>
@@ -5021,7 +4625,7 @@
         </p:nvSpPr>
         <p:spPr>
           <a:xfrm>
-            <a:off x="15209335" y="9009935"/>
+            <a:off x="15546812" y="9013371"/>
             <a:ext cx="850168" cy="405800"/>
           </a:xfrm>
           <a:prstGeom prst="rect">
@@ -5208,20 +4812,20 @@
             <a:r>
               <a:rPr lang="en-US" sz="3600" dirty="0">
                 <a:solidFill>
-                  <a:srgbClr val="2B83E6"/>
-                </a:solidFill>
-                <a:latin typeface="Montserrat" pitchFamily="2" charset="77"/>
+                  <a:srgbClr val="E77429"/>
+                </a:solidFill>
+                <a:latin typeface="Arial" panose="020B0604020202020204" pitchFamily="34" charset="0"/>
                 <a:ea typeface="+mn-lt"/>
-                <a:cs typeface="+mn-lt"/>
+                <a:cs typeface="Arial" panose="020B0604020202020204" pitchFamily="34" charset="0"/>
               </a:rPr>
               <a:t>”</a:t>
             </a:r>
             <a:endParaRPr lang="en-US" sz="3600" dirty="0">
               <a:solidFill>
-                <a:srgbClr val="2B83E6"/>
+                <a:srgbClr val="E77429"/>
               </a:solidFill>
-              <a:latin typeface="Montserrat" pitchFamily="2" charset="77"/>
-              <a:cs typeface="Arial"/>
+              <a:latin typeface="Arial" panose="020B0604020202020204" pitchFamily="34" charset="0"/>
+              <a:cs typeface="Arial" panose="020B0604020202020204" pitchFamily="34" charset="0"/>
             </a:endParaRPr>
           </a:p>
         </p:txBody>

</xml_diff>

<commit_message>
Fix presentation template placeholders
</commit_message>
<xml_diff>
--- a/mcp-server/assets/presentation.pptx
+++ b/mcp-server/assets/presentation.pptx
@@ -1674,7 +1674,7 @@
                 <a:ea typeface="+mn-lt"/>
                 <a:cs typeface="Arial" panose="020B0604020202020204" pitchFamily="34" charset="0"/>
               </a:rPr>
-              <a:t>{{DREAM}</a:t>
+              <a:t>{{DREAM}}</a:t>
             </a:r>
             <a:endParaRPr lang="en-US" sz="1200" dirty="0">
               <a:solidFill>
@@ -4818,7 +4818,7 @@
                 <a:ea typeface="+mn-lt"/>
                 <a:cs typeface="Arial" panose="020B0604020202020204" pitchFamily="34" charset="0"/>
               </a:rPr>
-              <a:t>”</a:t>
+              <a:t/>
             </a:r>
             <a:endParaRPr lang="en-US" sz="3600" dirty="0">
               <a:solidFill>

</xml_diff>